<commit_message>
wine, working with csv
</commit_message>
<xml_diff>
--- a/ppts/5 - Model quality.pptx
+++ b/ppts/5 - Model quality.pptx
@@ -4187,7 +4187,7 @@
           <a:p>
             <a:fld id="{15E4F5CE-CB34-4A0C-9595-867A2C0DB20E}" type="datetimeFigureOut">
               <a:rPr lang="nl-BE" smtClean="0"/>
-              <a:t>29/05/2026</a:t>
+              <a:t>1/06/2026</a:t>
             </a:fld>
             <a:endParaRPr lang="nl-BE"/>
           </a:p>
@@ -4364,7 +4364,7 @@
           <a:p>
             <a:fld id="{4D53584B-980D-4F7D-BA36-682FCDF648BB}" type="datetimeFigureOut">
               <a:rPr lang="nl-BE" smtClean="0"/>
-              <a:t>29/05/2026</a:t>
+              <a:t>1/06/2026</a:t>
             </a:fld>
             <a:endParaRPr lang="nl-BE"/>
           </a:p>
@@ -4988,7 +4988,7 @@
           <a:p>
             <a:fld id="{F456E141-11F1-487F-A892-18B8A63336C7}" type="datetime1">
               <a:rPr lang="nl-BE" smtClean="0"/>
-              <a:t>29/05/2026</a:t>
+              <a:t>1/06/2026</a:t>
             </a:fld>
             <a:endParaRPr lang="nl-BE"/>
           </a:p>
@@ -5304,7 +5304,7 @@
           <a:p>
             <a:fld id="{85CAFD92-94F2-4CD0-8A1D-AA3295115CEC}" type="datetime1">
               <a:rPr lang="nl-BE" smtClean="0"/>
-              <a:t>29/05/2026</a:t>
+              <a:t>1/06/2026</a:t>
             </a:fld>
             <a:endParaRPr lang="nl-BE"/>
           </a:p>
@@ -5484,7 +5484,7 @@
           <a:p>
             <a:fld id="{02B84EFA-B363-4043-A12E-44B39EC7D05B}" type="datetime1">
               <a:rPr lang="nl-BE" smtClean="0"/>
-              <a:t>29/05/2026</a:t>
+              <a:t>1/06/2026</a:t>
             </a:fld>
             <a:endParaRPr lang="nl-BE"/>
           </a:p>
@@ -5683,7 +5683,7 @@
           <a:p>
             <a:fld id="{B7AA89A6-C9B9-4556-BC9E-5E3CF3322A33}" type="datetime1">
               <a:rPr lang="nl-BE" smtClean="0"/>
-              <a:t>29/05/2026</a:t>
+              <a:t>1/06/2026</a:t>
             </a:fld>
             <a:endParaRPr lang="nl-BE"/>
           </a:p>
@@ -5934,7 +5934,7 @@
           <a:p>
             <a:fld id="{6CEB42D4-4FBB-465F-AE58-8ADBDBF671C8}" type="datetime1">
               <a:rPr lang="nl-BE" smtClean="0"/>
-              <a:t>29/05/2026</a:t>
+              <a:t>1/06/2026</a:t>
             </a:fld>
             <a:endParaRPr lang="nl-BE"/>
           </a:p>
@@ -6166,7 +6166,7 @@
           <a:p>
             <a:fld id="{64B405D5-C0FD-42E0-9EB1-2670F471B7BB}" type="datetime1">
               <a:rPr lang="nl-BE" smtClean="0"/>
-              <a:t>29/05/2026</a:t>
+              <a:t>1/06/2026</a:t>
             </a:fld>
             <a:endParaRPr lang="nl-BE"/>
           </a:p>
@@ -6533,7 +6533,7 @@
           <a:p>
             <a:fld id="{4CB55C39-C031-448F-A58F-CA88F7B6F786}" type="datetime1">
               <a:rPr lang="nl-BE" smtClean="0"/>
-              <a:t>29/05/2026</a:t>
+              <a:t>1/06/2026</a:t>
             </a:fld>
             <a:endParaRPr lang="nl-BE"/>
           </a:p>
@@ -6651,7 +6651,7 @@
           <a:p>
             <a:fld id="{E29307F5-1DF0-4FFF-91A4-1E1A6A26A94A}" type="datetime1">
               <a:rPr lang="nl-BE" smtClean="0"/>
-              <a:t>29/05/2026</a:t>
+              <a:t>1/06/2026</a:t>
             </a:fld>
             <a:endParaRPr lang="nl-BE"/>
           </a:p>
@@ -6746,7 +6746,7 @@
           <a:p>
             <a:fld id="{00A9168B-A159-4E9D-A6C6-C6786C6AB2EB}" type="datetime1">
               <a:rPr lang="nl-BE" smtClean="0"/>
-              <a:t>29/05/2026</a:t>
+              <a:t>1/06/2026</a:t>
             </a:fld>
             <a:endParaRPr lang="nl-BE"/>
           </a:p>
@@ -7023,7 +7023,7 @@
           <a:p>
             <a:fld id="{E9D22159-AF82-4D23-BC06-D4277BDD9BAD}" type="datetime1">
               <a:rPr lang="nl-BE" smtClean="0"/>
-              <a:t>29/05/2026</a:t>
+              <a:t>1/06/2026</a:t>
             </a:fld>
             <a:endParaRPr lang="nl-BE"/>
           </a:p>
@@ -7276,7 +7276,7 @@
           <a:p>
             <a:fld id="{D08A7014-C292-4E4F-926C-1A31F538B52A}" type="datetime1">
               <a:rPr lang="nl-BE" smtClean="0"/>
-              <a:t>29/05/2026</a:t>
+              <a:t>1/06/2026</a:t>
             </a:fld>
             <a:endParaRPr lang="nl-BE"/>
           </a:p>
@@ -7489,7 +7489,7 @@
           <a:p>
             <a:fld id="{E9CC7161-F687-474C-905A-3CCBBA535086}" type="datetime1">
               <a:rPr lang="nl-BE" smtClean="0"/>
-              <a:t>29/05/2026</a:t>
+              <a:t>1/06/2026</a:t>
             </a:fld>
             <a:endParaRPr lang="nl-BE"/>
           </a:p>
@@ -10737,7 +10737,7 @@
         </p:blipFill>
         <p:spPr>
           <a:xfrm>
-            <a:off x="2484133" y="2480187"/>
+            <a:off x="2468230" y="2337063"/>
             <a:ext cx="1481636" cy="1310977"/>
           </a:xfrm>
           <a:prstGeom prst="rect">

</xml_diff>